<commit_message>
Product Variant- show created data at data table
</commit_message>
<xml_diff>
--- a/.lessons/58 Backend Product And Related Features/20 Product Variant- working with create feature/1.pptx
+++ b/.lessons/58 Backend Product And Related Features/20 Product Variant- working with create feature/1.pptx
@@ -6,8 +6,17 @@
   </p:sldMasterIdLst>
   <p:sldIdLst>
     <p:sldId id="413" r:id="rId2"/>
-    <p:sldId id="414" r:id="rId3"/>
-    <p:sldId id="400" r:id="rId4"/>
+    <p:sldId id="415" r:id="rId3"/>
+    <p:sldId id="416" r:id="rId4"/>
+    <p:sldId id="417" r:id="rId5"/>
+    <p:sldId id="418" r:id="rId6"/>
+    <p:sldId id="419" r:id="rId7"/>
+    <p:sldId id="420" r:id="rId8"/>
+    <p:sldId id="421" r:id="rId9"/>
+    <p:sldId id="414" r:id="rId10"/>
+    <p:sldId id="422" r:id="rId11"/>
+    <p:sldId id="400" r:id="rId12"/>
+    <p:sldId id="423" r:id="rId13"/>
   </p:sldIdLst>
   <p:sldSz cx="12192000" cy="6858000"/>
   <p:notesSz cx="6858000" cy="9144000"/>
@@ -261,7 +270,7 @@
           <a:p>
             <a:fld id="{3E102D2E-813C-461C-9963-687A650C48C0}" type="datetimeFigureOut">
               <a:rPr lang="en-US" smtClean="0"/>
-              <a:t>6/26/2025</a:t>
+              <a:t>10/9/2025</a:t>
             </a:fld>
             <a:endParaRPr lang="en-US"/>
           </a:p>
@@ -459,7 +468,7 @@
           <a:p>
             <a:fld id="{3E102D2E-813C-461C-9963-687A650C48C0}" type="datetimeFigureOut">
               <a:rPr lang="en-US" smtClean="0"/>
-              <a:t>6/26/2025</a:t>
+              <a:t>10/9/2025</a:t>
             </a:fld>
             <a:endParaRPr lang="en-US"/>
           </a:p>
@@ -667,7 +676,7 @@
           <a:p>
             <a:fld id="{3E102D2E-813C-461C-9963-687A650C48C0}" type="datetimeFigureOut">
               <a:rPr lang="en-US" smtClean="0"/>
-              <a:t>6/26/2025</a:t>
+              <a:t>10/9/2025</a:t>
             </a:fld>
             <a:endParaRPr lang="en-US"/>
           </a:p>
@@ -865,7 +874,7 @@
           <a:p>
             <a:fld id="{3E102D2E-813C-461C-9963-687A650C48C0}" type="datetimeFigureOut">
               <a:rPr lang="en-US" smtClean="0"/>
-              <a:t>6/26/2025</a:t>
+              <a:t>10/9/2025</a:t>
             </a:fld>
             <a:endParaRPr lang="en-US"/>
           </a:p>
@@ -1140,7 +1149,7 @@
           <a:p>
             <a:fld id="{3E102D2E-813C-461C-9963-687A650C48C0}" type="datetimeFigureOut">
               <a:rPr lang="en-US" smtClean="0"/>
-              <a:t>6/26/2025</a:t>
+              <a:t>10/9/2025</a:t>
             </a:fld>
             <a:endParaRPr lang="en-US"/>
           </a:p>
@@ -1405,7 +1414,7 @@
           <a:p>
             <a:fld id="{3E102D2E-813C-461C-9963-687A650C48C0}" type="datetimeFigureOut">
               <a:rPr lang="en-US" smtClean="0"/>
-              <a:t>6/26/2025</a:t>
+              <a:t>10/9/2025</a:t>
             </a:fld>
             <a:endParaRPr lang="en-US"/>
           </a:p>
@@ -1817,7 +1826,7 @@
           <a:p>
             <a:fld id="{3E102D2E-813C-461C-9963-687A650C48C0}" type="datetimeFigureOut">
               <a:rPr lang="en-US" smtClean="0"/>
-              <a:t>6/26/2025</a:t>
+              <a:t>10/9/2025</a:t>
             </a:fld>
             <a:endParaRPr lang="en-US"/>
           </a:p>
@@ -1958,7 +1967,7 @@
           <a:p>
             <a:fld id="{3E102D2E-813C-461C-9963-687A650C48C0}" type="datetimeFigureOut">
               <a:rPr lang="en-US" smtClean="0"/>
-              <a:t>6/26/2025</a:t>
+              <a:t>10/9/2025</a:t>
             </a:fld>
             <a:endParaRPr lang="en-US"/>
           </a:p>
@@ -2071,7 +2080,7 @@
           <a:p>
             <a:fld id="{3E102D2E-813C-461C-9963-687A650C48C0}" type="datetimeFigureOut">
               <a:rPr lang="en-US" smtClean="0"/>
-              <a:t>6/26/2025</a:t>
+              <a:t>10/9/2025</a:t>
             </a:fld>
             <a:endParaRPr lang="en-US"/>
           </a:p>
@@ -2382,7 +2391,7 @@
           <a:p>
             <a:fld id="{3E102D2E-813C-461C-9963-687A650C48C0}" type="datetimeFigureOut">
               <a:rPr lang="en-US" smtClean="0"/>
-              <a:t>6/26/2025</a:t>
+              <a:t>10/9/2025</a:t>
             </a:fld>
             <a:endParaRPr lang="en-US"/>
           </a:p>
@@ -2670,7 +2679,7 @@
           <a:p>
             <a:fld id="{3E102D2E-813C-461C-9963-687A650C48C0}" type="datetimeFigureOut">
               <a:rPr lang="en-US" smtClean="0"/>
-              <a:t>6/26/2025</a:t>
+              <a:t>10/9/2025</a:t>
             </a:fld>
             <a:endParaRPr lang="en-US"/>
           </a:p>
@@ -2911,7 +2920,7 @@
           <a:p>
             <a:fld id="{3E102D2E-813C-461C-9963-687A650C48C0}" type="datetimeFigureOut">
               <a:rPr lang="en-US" smtClean="0"/>
-              <a:t>6/26/2025</a:t>
+              <a:t>10/9/2025</a:t>
             </a:fld>
             <a:endParaRPr lang="en-US"/>
           </a:p>
@@ -3369,21 +3378,54 @@
               <a:buNone/>
             </a:pPr>
             <a:r>
-              <a:rPr kumimoji="0" lang="en-US" altLang="en-US" sz="1300" b="0" i="0" u="none" strike="noStrike" cap="none" normalizeH="0" baseline="0">
-                <a:ln>
-                  <a:noFill/>
-                </a:ln>
-                <a:solidFill>
-                  <a:schemeClr val="tx1"/>
-                </a:solidFill>
-                <a:effectLst/>
+              <a:rPr lang="en-US" altLang="en-US" sz="1300">
                 <a:latin typeface="Arial" panose="020B0604020202020204" pitchFamily="34" charset="0"/>
               </a:rPr>
-              <a:t>.</a:t>
-            </a:r>
-          </a:p>
-        </p:txBody>
-      </p:sp>
+              <a:t>app\Http\Controllers\Backend\ProductVariantController.php</a:t>
+            </a:r>
+            <a:endParaRPr kumimoji="0" lang="en-US" altLang="en-US" sz="1300" b="0" i="0" u="none" strike="noStrike" cap="none" normalizeH="0" baseline="0">
+              <a:ln>
+                <a:noFill/>
+              </a:ln>
+              <a:solidFill>
+                <a:schemeClr val="tx1"/>
+              </a:solidFill>
+              <a:effectLst/>
+              <a:latin typeface="Arial" panose="020B0604020202020204" pitchFamily="34" charset="0"/>
+            </a:endParaRPr>
+          </a:p>
+        </p:txBody>
+      </p:sp>
+      <p:pic>
+        <p:nvPicPr>
+          <p:cNvPr id="4" name="Picture 3">
+            <a:extLst>
+              <a:ext uri="{FF2B5EF4-FFF2-40B4-BE49-F238E27FC236}">
+                <a16:creationId xmlns:a16="http://schemas.microsoft.com/office/drawing/2014/main" id="{F9CCC480-BAD7-B32F-87A7-16EC469B0F30}"/>
+              </a:ext>
+            </a:extLst>
+          </p:cNvPr>
+          <p:cNvPicPr>
+            <a:picLocks noChangeAspect="1"/>
+          </p:cNvPicPr>
+          <p:nvPr/>
+        </p:nvPicPr>
+        <p:blipFill>
+          <a:blip r:embed="rId2"/>
+          <a:stretch>
+            <a:fillRect/>
+          </a:stretch>
+        </p:blipFill>
+        <p:spPr>
+          <a:xfrm>
+            <a:off x="6628482" y="-6927"/>
+            <a:ext cx="5563518" cy="6858000"/>
+          </a:xfrm>
+          <a:prstGeom prst="rect">
+            <a:avLst/>
+          </a:prstGeom>
+        </p:spPr>
+      </p:pic>
     </p:spTree>
     <p:extLst>
       <p:ext uri="{BB962C8B-B14F-4D97-AF65-F5344CB8AC3E}">
@@ -3397,7 +3439,1269 @@
 </p:sld>
 </file>
 
+<file path=ppt/slides/slide10.xml><?xml version="1.0" encoding="utf-8"?>
+<p:sld xmlns:a="http://schemas.openxmlformats.org/drawingml/2006/main" xmlns:r="http://schemas.openxmlformats.org/officeDocument/2006/relationships" xmlns:p="http://schemas.openxmlformats.org/presentationml/2006/main">
+  <p:cSld>
+    <p:spTree>
+      <p:nvGrpSpPr>
+        <p:cNvPr id="1" name="">
+          <a:extLst>
+            <a:ext uri="{FF2B5EF4-FFF2-40B4-BE49-F238E27FC236}">
+              <a16:creationId xmlns:a16="http://schemas.microsoft.com/office/drawing/2014/main" id="{D279D326-0A35-06B7-204B-58A746258001}"/>
+            </a:ext>
+          </a:extLst>
+        </p:cNvPr>
+        <p:cNvGrpSpPr/>
+        <p:nvPr/>
+      </p:nvGrpSpPr>
+      <p:grpSpPr>
+        <a:xfrm>
+          <a:off x="0" y="0"/>
+          <a:ext cx="0" cy="0"/>
+          <a:chOff x="0" y="0"/>
+          <a:chExt cx="0" cy="0"/>
+        </a:xfrm>
+      </p:grpSpPr>
+      <p:sp>
+        <p:nvSpPr>
+          <p:cNvPr id="3" name="TextBox 2">
+            <a:extLst>
+              <a:ext uri="{FF2B5EF4-FFF2-40B4-BE49-F238E27FC236}">
+                <a16:creationId xmlns:a16="http://schemas.microsoft.com/office/drawing/2014/main" id="{B487F570-9B45-A1F2-3E9E-ADFEDC1558AD}"/>
+              </a:ext>
+            </a:extLst>
+          </p:cNvPr>
+          <p:cNvSpPr txBox="1"/>
+          <p:nvPr/>
+        </p:nvSpPr>
+        <p:spPr>
+          <a:xfrm>
+            <a:off x="217714" y="255046"/>
+            <a:ext cx="11756571" cy="355354"/>
+          </a:xfrm>
+          <a:prstGeom prst="rect">
+            <a:avLst/>
+          </a:prstGeom>
+          <a:noFill/>
+        </p:spPr>
+        <p:txBody>
+          <a:bodyPr wrap="square">
+            <a:spAutoFit/>
+          </a:bodyPr>
+          <a:lstStyle/>
+          <a:p>
+            <a:pPr>
+              <a:lnSpc>
+                <a:spcPct val="150000"/>
+              </a:lnSpc>
+              <a:buNone/>
+            </a:pPr>
+            <a:r>
+              <a:rPr kumimoji="0" lang="en-US" altLang="en-US" sz="1300" b="0" i="0" u="none" strike="noStrike" cap="none" normalizeH="0" baseline="0">
+                <a:ln>
+                  <a:noFill/>
+                </a:ln>
+                <a:solidFill>
+                  <a:schemeClr val="tx1"/>
+                </a:solidFill>
+                <a:effectLst/>
+                <a:latin typeface="Arial" panose="020B0604020202020204" pitchFamily="34" charset="0"/>
+              </a:rPr>
+              <a:t>.</a:t>
+            </a:r>
+          </a:p>
+        </p:txBody>
+      </p:sp>
+      <p:pic>
+        <p:nvPicPr>
+          <p:cNvPr id="4" name="Picture 3">
+            <a:extLst>
+              <a:ext uri="{FF2B5EF4-FFF2-40B4-BE49-F238E27FC236}">
+                <a16:creationId xmlns:a16="http://schemas.microsoft.com/office/drawing/2014/main" id="{8B635C17-829D-F963-3756-DB96DF479C96}"/>
+              </a:ext>
+            </a:extLst>
+          </p:cNvPr>
+          <p:cNvPicPr>
+            <a:picLocks noChangeAspect="1"/>
+          </p:cNvPicPr>
+          <p:nvPr/>
+        </p:nvPicPr>
+        <p:blipFill>
+          <a:blip r:embed="rId2"/>
+          <a:stretch>
+            <a:fillRect/>
+          </a:stretch>
+        </p:blipFill>
+        <p:spPr>
+          <a:xfrm>
+            <a:off x="1309019" y="1147444"/>
+            <a:ext cx="9573961" cy="4563112"/>
+          </a:xfrm>
+          <a:prstGeom prst="rect">
+            <a:avLst/>
+          </a:prstGeom>
+          <a:ln>
+            <a:noFill/>
+          </a:ln>
+          <a:effectLst>
+            <a:outerShdw blurRad="292100" dist="139700" dir="2700000" algn="tl" rotWithShape="0">
+              <a:srgbClr val="333333">
+                <a:alpha val="65000"/>
+              </a:srgbClr>
+            </a:outerShdw>
+          </a:effectLst>
+        </p:spPr>
+      </p:pic>
+    </p:spTree>
+    <p:extLst>
+      <p:ext uri="{BB962C8B-B14F-4D97-AF65-F5344CB8AC3E}">
+        <p14:creationId xmlns:p14="http://schemas.microsoft.com/office/powerpoint/2010/main" val="1758352427"/>
+      </p:ext>
+    </p:extLst>
+  </p:cSld>
+  <p:clrMapOvr>
+    <a:masterClrMapping/>
+  </p:clrMapOvr>
+</p:sld>
+</file>
+
+<file path=ppt/slides/slide11.xml><?xml version="1.0" encoding="utf-8"?>
+<p:sld xmlns:a="http://schemas.openxmlformats.org/drawingml/2006/main" xmlns:r="http://schemas.openxmlformats.org/officeDocument/2006/relationships" xmlns:p="http://schemas.openxmlformats.org/presentationml/2006/main">
+  <p:cSld>
+    <p:spTree>
+      <p:nvGrpSpPr>
+        <p:cNvPr id="1" name="">
+          <a:extLst>
+            <a:ext uri="{FF2B5EF4-FFF2-40B4-BE49-F238E27FC236}">
+              <a16:creationId xmlns:a16="http://schemas.microsoft.com/office/drawing/2014/main" id="{ECE25D7D-A080-F22B-7E8D-36EC827289A1}"/>
+            </a:ext>
+          </a:extLst>
+        </p:cNvPr>
+        <p:cNvGrpSpPr/>
+        <p:nvPr/>
+      </p:nvGrpSpPr>
+      <p:grpSpPr>
+        <a:xfrm>
+          <a:off x="0" y="0"/>
+          <a:ext cx="0" cy="0"/>
+          <a:chOff x="0" y="0"/>
+          <a:chExt cx="0" cy="0"/>
+        </a:xfrm>
+      </p:grpSpPr>
+      <p:sp>
+        <p:nvSpPr>
+          <p:cNvPr id="3" name="TextBox 2">
+            <a:extLst>
+              <a:ext uri="{FF2B5EF4-FFF2-40B4-BE49-F238E27FC236}">
+                <a16:creationId xmlns:a16="http://schemas.microsoft.com/office/drawing/2014/main" id="{E33F16A3-A6E8-401E-847B-09570DC6E4CB}"/>
+              </a:ext>
+            </a:extLst>
+          </p:cNvPr>
+          <p:cNvSpPr txBox="1"/>
+          <p:nvPr/>
+        </p:nvSpPr>
+        <p:spPr>
+          <a:xfrm>
+            <a:off x="217714" y="255046"/>
+            <a:ext cx="11756571" cy="355354"/>
+          </a:xfrm>
+          <a:prstGeom prst="rect">
+            <a:avLst/>
+          </a:prstGeom>
+          <a:noFill/>
+        </p:spPr>
+        <p:txBody>
+          <a:bodyPr wrap="square">
+            <a:spAutoFit/>
+          </a:bodyPr>
+          <a:lstStyle/>
+          <a:p>
+            <a:pPr>
+              <a:lnSpc>
+                <a:spcPct val="150000"/>
+              </a:lnSpc>
+              <a:buNone/>
+            </a:pPr>
+            <a:r>
+              <a:rPr kumimoji="0" lang="en-US" altLang="en-US" sz="1300" b="0" i="0" u="none" strike="noStrike" cap="none" normalizeH="0" baseline="0">
+                <a:ln>
+                  <a:noFill/>
+                </a:ln>
+                <a:solidFill>
+                  <a:schemeClr val="tx1"/>
+                </a:solidFill>
+                <a:effectLst/>
+                <a:latin typeface="Arial" panose="020B0604020202020204" pitchFamily="34" charset="0"/>
+              </a:rPr>
+              <a:t>.</a:t>
+            </a:r>
+          </a:p>
+        </p:txBody>
+      </p:sp>
+    </p:spTree>
+    <p:extLst>
+      <p:ext uri="{BB962C8B-B14F-4D97-AF65-F5344CB8AC3E}">
+        <p14:creationId xmlns:p14="http://schemas.microsoft.com/office/powerpoint/2010/main" val="3095838342"/>
+      </p:ext>
+    </p:extLst>
+  </p:cSld>
+  <p:clrMapOvr>
+    <a:masterClrMapping/>
+  </p:clrMapOvr>
+</p:sld>
+</file>
+
+<file path=ppt/slides/slide12.xml><?xml version="1.0" encoding="utf-8"?>
+<p:sld xmlns:a="http://schemas.openxmlformats.org/drawingml/2006/main" xmlns:r="http://schemas.openxmlformats.org/officeDocument/2006/relationships" xmlns:p="http://schemas.openxmlformats.org/presentationml/2006/main">
+  <p:cSld>
+    <p:spTree>
+      <p:nvGrpSpPr>
+        <p:cNvPr id="1" name="">
+          <a:extLst>
+            <a:ext uri="{FF2B5EF4-FFF2-40B4-BE49-F238E27FC236}">
+              <a16:creationId xmlns:a16="http://schemas.microsoft.com/office/drawing/2014/main" id="{BC8D6A7A-3253-A177-1F90-0AE5CDD7B112}"/>
+            </a:ext>
+          </a:extLst>
+        </p:cNvPr>
+        <p:cNvGrpSpPr/>
+        <p:nvPr/>
+      </p:nvGrpSpPr>
+      <p:grpSpPr>
+        <a:xfrm>
+          <a:off x="0" y="0"/>
+          <a:ext cx="0" cy="0"/>
+          <a:chOff x="0" y="0"/>
+          <a:chExt cx="0" cy="0"/>
+        </a:xfrm>
+      </p:grpSpPr>
+      <p:sp>
+        <p:nvSpPr>
+          <p:cNvPr id="3" name="TextBox 2">
+            <a:extLst>
+              <a:ext uri="{FF2B5EF4-FFF2-40B4-BE49-F238E27FC236}">
+                <a16:creationId xmlns:a16="http://schemas.microsoft.com/office/drawing/2014/main" id="{3CEF9C93-C346-EB1C-95A0-A043BC74F042}"/>
+              </a:ext>
+            </a:extLst>
+          </p:cNvPr>
+          <p:cNvSpPr txBox="1"/>
+          <p:nvPr/>
+        </p:nvSpPr>
+        <p:spPr>
+          <a:xfrm>
+            <a:off x="217714" y="255046"/>
+            <a:ext cx="11756571" cy="355354"/>
+          </a:xfrm>
+          <a:prstGeom prst="rect">
+            <a:avLst/>
+          </a:prstGeom>
+          <a:noFill/>
+        </p:spPr>
+        <p:txBody>
+          <a:bodyPr wrap="square">
+            <a:spAutoFit/>
+          </a:bodyPr>
+          <a:lstStyle/>
+          <a:p>
+            <a:pPr>
+              <a:lnSpc>
+                <a:spcPct val="150000"/>
+              </a:lnSpc>
+              <a:buNone/>
+            </a:pPr>
+            <a:r>
+              <a:rPr kumimoji="0" lang="en-US" altLang="en-US" sz="1300" b="0" i="0" u="none" strike="noStrike" cap="none" normalizeH="0" baseline="0">
+                <a:ln>
+                  <a:noFill/>
+                </a:ln>
+                <a:solidFill>
+                  <a:schemeClr val="tx1"/>
+                </a:solidFill>
+                <a:effectLst/>
+                <a:latin typeface="Arial" panose="020B0604020202020204" pitchFamily="34" charset="0"/>
+              </a:rPr>
+              <a:t>.</a:t>
+            </a:r>
+          </a:p>
+        </p:txBody>
+      </p:sp>
+    </p:spTree>
+    <p:extLst>
+      <p:ext uri="{BB962C8B-B14F-4D97-AF65-F5344CB8AC3E}">
+        <p14:creationId xmlns:p14="http://schemas.microsoft.com/office/powerpoint/2010/main" val="4283664970"/>
+      </p:ext>
+    </p:extLst>
+  </p:cSld>
+  <p:clrMapOvr>
+    <a:masterClrMapping/>
+  </p:clrMapOvr>
+</p:sld>
+</file>
+
 <file path=ppt/slides/slide2.xml><?xml version="1.0" encoding="utf-8"?>
+<p:sld xmlns:a="http://schemas.openxmlformats.org/drawingml/2006/main" xmlns:r="http://schemas.openxmlformats.org/officeDocument/2006/relationships" xmlns:p="http://schemas.openxmlformats.org/presentationml/2006/main">
+  <p:cSld>
+    <p:spTree>
+      <p:nvGrpSpPr>
+        <p:cNvPr id="1" name="">
+          <a:extLst>
+            <a:ext uri="{FF2B5EF4-FFF2-40B4-BE49-F238E27FC236}">
+              <a16:creationId xmlns:a16="http://schemas.microsoft.com/office/drawing/2014/main" id="{3405DE39-3014-B280-466F-E03D970A7C22}"/>
+            </a:ext>
+          </a:extLst>
+        </p:cNvPr>
+        <p:cNvGrpSpPr/>
+        <p:nvPr/>
+      </p:nvGrpSpPr>
+      <p:grpSpPr>
+        <a:xfrm>
+          <a:off x="0" y="0"/>
+          <a:ext cx="0" cy="0"/>
+          <a:chOff x="0" y="0"/>
+          <a:chExt cx="0" cy="0"/>
+        </a:xfrm>
+      </p:grpSpPr>
+      <p:sp>
+        <p:nvSpPr>
+          <p:cNvPr id="3" name="TextBox 2">
+            <a:extLst>
+              <a:ext uri="{FF2B5EF4-FFF2-40B4-BE49-F238E27FC236}">
+                <a16:creationId xmlns:a16="http://schemas.microsoft.com/office/drawing/2014/main" id="{0BC81F13-2ACA-6D0F-BC72-AB48EA40F28B}"/>
+              </a:ext>
+            </a:extLst>
+          </p:cNvPr>
+          <p:cNvSpPr txBox="1"/>
+          <p:nvPr/>
+        </p:nvSpPr>
+        <p:spPr>
+          <a:xfrm>
+            <a:off x="217714" y="255046"/>
+            <a:ext cx="11756571" cy="355354"/>
+          </a:xfrm>
+          <a:prstGeom prst="rect">
+            <a:avLst/>
+          </a:prstGeom>
+          <a:noFill/>
+        </p:spPr>
+        <p:txBody>
+          <a:bodyPr wrap="square">
+            <a:spAutoFit/>
+          </a:bodyPr>
+          <a:lstStyle/>
+          <a:p>
+            <a:pPr>
+              <a:lnSpc>
+                <a:spcPct val="150000"/>
+              </a:lnSpc>
+              <a:buNone/>
+            </a:pPr>
+            <a:r>
+              <a:rPr lang="en-US" altLang="en-US" sz="1300">
+                <a:latin typeface="Arial" panose="020B0604020202020204" pitchFamily="34" charset="0"/>
+              </a:rPr>
+              <a:t>resources\views\admin\product\product-variant\create.blade.php</a:t>
+            </a:r>
+            <a:endParaRPr kumimoji="0" lang="en-US" altLang="en-US" sz="1300" b="0" i="0" u="none" strike="noStrike" cap="none" normalizeH="0" baseline="0">
+              <a:ln>
+                <a:noFill/>
+              </a:ln>
+              <a:solidFill>
+                <a:schemeClr val="tx1"/>
+              </a:solidFill>
+              <a:effectLst/>
+              <a:latin typeface="Arial" panose="020B0604020202020204" pitchFamily="34" charset="0"/>
+            </a:endParaRPr>
+          </a:p>
+        </p:txBody>
+      </p:sp>
+      <p:pic>
+        <p:nvPicPr>
+          <p:cNvPr id="4" name="Picture 3">
+            <a:extLst>
+              <a:ext uri="{FF2B5EF4-FFF2-40B4-BE49-F238E27FC236}">
+                <a16:creationId xmlns:a16="http://schemas.microsoft.com/office/drawing/2014/main" id="{3EABFB9F-3803-5FA2-93C5-7CEF58FAF1A7}"/>
+              </a:ext>
+            </a:extLst>
+          </p:cNvPr>
+          <p:cNvPicPr>
+            <a:picLocks noChangeAspect="1"/>
+          </p:cNvPicPr>
+          <p:nvPr/>
+        </p:nvPicPr>
+        <p:blipFill>
+          <a:blip r:embed="rId2"/>
+          <a:stretch>
+            <a:fillRect/>
+          </a:stretch>
+        </p:blipFill>
+        <p:spPr>
+          <a:xfrm>
+            <a:off x="5422976" y="0"/>
+            <a:ext cx="6769024" cy="6858000"/>
+          </a:xfrm>
+          <a:prstGeom prst="rect">
+            <a:avLst/>
+          </a:prstGeom>
+        </p:spPr>
+      </p:pic>
+    </p:spTree>
+    <p:extLst>
+      <p:ext uri="{BB962C8B-B14F-4D97-AF65-F5344CB8AC3E}">
+        <p14:creationId xmlns:p14="http://schemas.microsoft.com/office/powerpoint/2010/main" val="1879157961"/>
+      </p:ext>
+    </p:extLst>
+  </p:cSld>
+  <p:clrMapOvr>
+    <a:masterClrMapping/>
+  </p:clrMapOvr>
+</p:sld>
+</file>
+
+<file path=ppt/slides/slide3.xml><?xml version="1.0" encoding="utf-8"?>
+<p:sld xmlns:a="http://schemas.openxmlformats.org/drawingml/2006/main" xmlns:r="http://schemas.openxmlformats.org/officeDocument/2006/relationships" xmlns:p="http://schemas.openxmlformats.org/presentationml/2006/main">
+  <p:cSld>
+    <p:spTree>
+      <p:nvGrpSpPr>
+        <p:cNvPr id="1" name="">
+          <a:extLst>
+            <a:ext uri="{FF2B5EF4-FFF2-40B4-BE49-F238E27FC236}">
+              <a16:creationId xmlns:a16="http://schemas.microsoft.com/office/drawing/2014/main" id="{E0817D01-CE31-E717-F885-1C49AC46A0BE}"/>
+            </a:ext>
+          </a:extLst>
+        </p:cNvPr>
+        <p:cNvGrpSpPr/>
+        <p:nvPr/>
+      </p:nvGrpSpPr>
+      <p:grpSpPr>
+        <a:xfrm>
+          <a:off x="0" y="0"/>
+          <a:ext cx="0" cy="0"/>
+          <a:chOff x="0" y="0"/>
+          <a:chExt cx="0" cy="0"/>
+        </a:xfrm>
+      </p:grpSpPr>
+      <p:sp>
+        <p:nvSpPr>
+          <p:cNvPr id="3" name="TextBox 2">
+            <a:extLst>
+              <a:ext uri="{FF2B5EF4-FFF2-40B4-BE49-F238E27FC236}">
+                <a16:creationId xmlns:a16="http://schemas.microsoft.com/office/drawing/2014/main" id="{E6392FDC-E261-1B39-179A-73BEE41552E8}"/>
+              </a:ext>
+            </a:extLst>
+          </p:cNvPr>
+          <p:cNvSpPr txBox="1"/>
+          <p:nvPr/>
+        </p:nvSpPr>
+        <p:spPr>
+          <a:xfrm>
+            <a:off x="217714" y="255046"/>
+            <a:ext cx="11756571" cy="355354"/>
+          </a:xfrm>
+          <a:prstGeom prst="rect">
+            <a:avLst/>
+          </a:prstGeom>
+          <a:noFill/>
+        </p:spPr>
+        <p:txBody>
+          <a:bodyPr wrap="square">
+            <a:spAutoFit/>
+          </a:bodyPr>
+          <a:lstStyle/>
+          <a:p>
+            <a:pPr>
+              <a:lnSpc>
+                <a:spcPct val="150000"/>
+              </a:lnSpc>
+              <a:buNone/>
+            </a:pPr>
+            <a:r>
+              <a:rPr lang="en-US" altLang="en-US" sz="1300">
+                <a:latin typeface="Arial" panose="020B0604020202020204" pitchFamily="34" charset="0"/>
+              </a:rPr>
+              <a:t>database\migrations\2025_10_08_121003_create_product_variants_table.php</a:t>
+            </a:r>
+            <a:endParaRPr kumimoji="0" lang="en-US" altLang="en-US" sz="1300" b="0" i="0" u="none" strike="noStrike" cap="none" normalizeH="0" baseline="0">
+              <a:ln>
+                <a:noFill/>
+              </a:ln>
+              <a:solidFill>
+                <a:schemeClr val="tx1"/>
+              </a:solidFill>
+              <a:effectLst/>
+              <a:latin typeface="Arial" panose="020B0604020202020204" pitchFamily="34" charset="0"/>
+            </a:endParaRPr>
+          </a:p>
+        </p:txBody>
+      </p:sp>
+      <p:pic>
+        <p:nvPicPr>
+          <p:cNvPr id="4" name="Picture 3">
+            <a:extLst>
+              <a:ext uri="{FF2B5EF4-FFF2-40B4-BE49-F238E27FC236}">
+                <a16:creationId xmlns:a16="http://schemas.microsoft.com/office/drawing/2014/main" id="{4AD5ABAF-3572-98BF-C4BC-51587A27D55B}"/>
+              </a:ext>
+            </a:extLst>
+          </p:cNvPr>
+          <p:cNvPicPr>
+            <a:picLocks noChangeAspect="1"/>
+          </p:cNvPicPr>
+          <p:nvPr/>
+        </p:nvPicPr>
+        <p:blipFill>
+          <a:blip r:embed="rId2"/>
+          <a:stretch>
+            <a:fillRect/>
+          </a:stretch>
+        </p:blipFill>
+        <p:spPr>
+          <a:xfrm>
+            <a:off x="6092877" y="0"/>
+            <a:ext cx="6099123" cy="6858000"/>
+          </a:xfrm>
+          <a:prstGeom prst="rect">
+            <a:avLst/>
+          </a:prstGeom>
+        </p:spPr>
+      </p:pic>
+    </p:spTree>
+    <p:extLst>
+      <p:ext uri="{BB962C8B-B14F-4D97-AF65-F5344CB8AC3E}">
+        <p14:creationId xmlns:p14="http://schemas.microsoft.com/office/powerpoint/2010/main" val="2845819843"/>
+      </p:ext>
+    </p:extLst>
+  </p:cSld>
+  <p:clrMapOvr>
+    <a:masterClrMapping/>
+  </p:clrMapOvr>
+</p:sld>
+</file>
+
+<file path=ppt/slides/slide4.xml><?xml version="1.0" encoding="utf-8"?>
+<p:sld xmlns:a="http://schemas.openxmlformats.org/drawingml/2006/main" xmlns:r="http://schemas.openxmlformats.org/officeDocument/2006/relationships" xmlns:p="http://schemas.openxmlformats.org/presentationml/2006/main">
+  <p:cSld>
+    <p:spTree>
+      <p:nvGrpSpPr>
+        <p:cNvPr id="1" name="">
+          <a:extLst>
+            <a:ext uri="{FF2B5EF4-FFF2-40B4-BE49-F238E27FC236}">
+              <a16:creationId xmlns:a16="http://schemas.microsoft.com/office/drawing/2014/main" id="{D707B8CF-6E62-FA71-84E3-83F060B6AE56}"/>
+            </a:ext>
+          </a:extLst>
+        </p:cNvPr>
+        <p:cNvGrpSpPr/>
+        <p:nvPr/>
+      </p:nvGrpSpPr>
+      <p:grpSpPr>
+        <a:xfrm>
+          <a:off x="0" y="0"/>
+          <a:ext cx="0" cy="0"/>
+          <a:chOff x="0" y="0"/>
+          <a:chExt cx="0" cy="0"/>
+        </a:xfrm>
+      </p:grpSpPr>
+      <p:sp>
+        <p:nvSpPr>
+          <p:cNvPr id="3" name="TextBox 2">
+            <a:extLst>
+              <a:ext uri="{FF2B5EF4-FFF2-40B4-BE49-F238E27FC236}">
+                <a16:creationId xmlns:a16="http://schemas.microsoft.com/office/drawing/2014/main" id="{80CFBCF2-D542-3B32-CF01-60D5879DA7B3}"/>
+              </a:ext>
+            </a:extLst>
+          </p:cNvPr>
+          <p:cNvSpPr txBox="1"/>
+          <p:nvPr/>
+        </p:nvSpPr>
+        <p:spPr>
+          <a:xfrm>
+            <a:off x="217714" y="255046"/>
+            <a:ext cx="11756571" cy="355354"/>
+          </a:xfrm>
+          <a:prstGeom prst="rect">
+            <a:avLst/>
+          </a:prstGeom>
+          <a:noFill/>
+        </p:spPr>
+        <p:txBody>
+          <a:bodyPr wrap="square">
+            <a:spAutoFit/>
+          </a:bodyPr>
+          <a:lstStyle/>
+          <a:p>
+            <a:pPr>
+              <a:lnSpc>
+                <a:spcPct val="150000"/>
+              </a:lnSpc>
+              <a:buNone/>
+            </a:pPr>
+            <a:r>
+              <a:rPr kumimoji="0" lang="en-US" altLang="en-US" sz="1300" b="0" i="0" u="none" strike="noStrike" cap="none" normalizeH="0" baseline="0">
+                <a:ln>
+                  <a:noFill/>
+                </a:ln>
+                <a:solidFill>
+                  <a:schemeClr val="tx1"/>
+                </a:solidFill>
+                <a:effectLst/>
+                <a:latin typeface="Arial" panose="020B0604020202020204" pitchFamily="34" charset="0"/>
+              </a:rPr>
+              <a:t>.</a:t>
+            </a:r>
+          </a:p>
+        </p:txBody>
+      </p:sp>
+      <p:pic>
+        <p:nvPicPr>
+          <p:cNvPr id="4" name="Picture 3">
+            <a:extLst>
+              <a:ext uri="{FF2B5EF4-FFF2-40B4-BE49-F238E27FC236}">
+                <a16:creationId xmlns:a16="http://schemas.microsoft.com/office/drawing/2014/main" id="{3A2339A0-4422-B84A-32EB-D3878C6DC041}"/>
+              </a:ext>
+            </a:extLst>
+          </p:cNvPr>
+          <p:cNvPicPr>
+            <a:picLocks noChangeAspect="1"/>
+          </p:cNvPicPr>
+          <p:nvPr/>
+        </p:nvPicPr>
+        <p:blipFill>
+          <a:blip r:embed="rId2"/>
+          <a:stretch>
+            <a:fillRect/>
+          </a:stretch>
+        </p:blipFill>
+        <p:spPr>
+          <a:xfrm>
+            <a:off x="889860" y="2538288"/>
+            <a:ext cx="10412278" cy="1781424"/>
+          </a:xfrm>
+          <a:prstGeom prst="rect">
+            <a:avLst/>
+          </a:prstGeom>
+        </p:spPr>
+      </p:pic>
+    </p:spTree>
+    <p:extLst>
+      <p:ext uri="{BB962C8B-B14F-4D97-AF65-F5344CB8AC3E}">
+        <p14:creationId xmlns:p14="http://schemas.microsoft.com/office/powerpoint/2010/main" val="895104758"/>
+      </p:ext>
+    </p:extLst>
+  </p:cSld>
+  <p:clrMapOvr>
+    <a:masterClrMapping/>
+  </p:clrMapOvr>
+</p:sld>
+</file>
+
+<file path=ppt/slides/slide5.xml><?xml version="1.0" encoding="utf-8"?>
+<p:sld xmlns:a="http://schemas.openxmlformats.org/drawingml/2006/main" xmlns:r="http://schemas.openxmlformats.org/officeDocument/2006/relationships" xmlns:p="http://schemas.openxmlformats.org/presentationml/2006/main">
+  <p:cSld>
+    <p:spTree>
+      <p:nvGrpSpPr>
+        <p:cNvPr id="1" name="">
+          <a:extLst>
+            <a:ext uri="{FF2B5EF4-FFF2-40B4-BE49-F238E27FC236}">
+              <a16:creationId xmlns:a16="http://schemas.microsoft.com/office/drawing/2014/main" id="{40BB675A-0C76-EC35-96C2-F9369D9F7FD4}"/>
+            </a:ext>
+          </a:extLst>
+        </p:cNvPr>
+        <p:cNvGrpSpPr/>
+        <p:nvPr/>
+      </p:nvGrpSpPr>
+      <p:grpSpPr>
+        <a:xfrm>
+          <a:off x="0" y="0"/>
+          <a:ext cx="0" cy="0"/>
+          <a:chOff x="0" y="0"/>
+          <a:chExt cx="0" cy="0"/>
+        </a:xfrm>
+      </p:grpSpPr>
+      <p:sp>
+        <p:nvSpPr>
+          <p:cNvPr id="3" name="TextBox 2">
+            <a:extLst>
+              <a:ext uri="{FF2B5EF4-FFF2-40B4-BE49-F238E27FC236}">
+                <a16:creationId xmlns:a16="http://schemas.microsoft.com/office/drawing/2014/main" id="{8C117805-BD61-4A68-0162-EBD8A022F860}"/>
+              </a:ext>
+            </a:extLst>
+          </p:cNvPr>
+          <p:cNvSpPr txBox="1"/>
+          <p:nvPr/>
+        </p:nvSpPr>
+        <p:spPr>
+          <a:xfrm>
+            <a:off x="217714" y="255046"/>
+            <a:ext cx="11756571" cy="355354"/>
+          </a:xfrm>
+          <a:prstGeom prst="rect">
+            <a:avLst/>
+          </a:prstGeom>
+          <a:noFill/>
+        </p:spPr>
+        <p:txBody>
+          <a:bodyPr wrap="square">
+            <a:spAutoFit/>
+          </a:bodyPr>
+          <a:lstStyle/>
+          <a:p>
+            <a:pPr>
+              <a:lnSpc>
+                <a:spcPct val="150000"/>
+              </a:lnSpc>
+              <a:buNone/>
+            </a:pPr>
+            <a:r>
+              <a:rPr kumimoji="0" lang="en-US" altLang="en-US" sz="1300" b="0" i="0" u="none" strike="noStrike" cap="none" normalizeH="0" baseline="0">
+                <a:ln>
+                  <a:noFill/>
+                </a:ln>
+                <a:solidFill>
+                  <a:schemeClr val="tx1"/>
+                </a:solidFill>
+                <a:effectLst/>
+                <a:latin typeface="Arial" panose="020B0604020202020204" pitchFamily="34" charset="0"/>
+              </a:rPr>
+              <a:t>.</a:t>
+            </a:r>
+          </a:p>
+        </p:txBody>
+      </p:sp>
+      <p:pic>
+        <p:nvPicPr>
+          <p:cNvPr id="4" name="Picture 3">
+            <a:extLst>
+              <a:ext uri="{FF2B5EF4-FFF2-40B4-BE49-F238E27FC236}">
+                <a16:creationId xmlns:a16="http://schemas.microsoft.com/office/drawing/2014/main" id="{94744C05-9120-2B8A-CBEC-F5960218027D}"/>
+              </a:ext>
+            </a:extLst>
+          </p:cNvPr>
+          <p:cNvPicPr>
+            <a:picLocks noChangeAspect="1"/>
+          </p:cNvPicPr>
+          <p:nvPr/>
+        </p:nvPicPr>
+        <p:blipFill>
+          <a:blip r:embed="rId2"/>
+          <a:stretch>
+            <a:fillRect/>
+          </a:stretch>
+        </p:blipFill>
+        <p:spPr>
+          <a:xfrm>
+            <a:off x="0" y="1445887"/>
+            <a:ext cx="12192000" cy="3966226"/>
+          </a:xfrm>
+          <a:prstGeom prst="rect">
+            <a:avLst/>
+          </a:prstGeom>
+          <a:ln>
+            <a:noFill/>
+          </a:ln>
+          <a:effectLst>
+            <a:outerShdw blurRad="292100" dist="139700" dir="2700000" algn="tl" rotWithShape="0">
+              <a:srgbClr val="333333">
+                <a:alpha val="65000"/>
+              </a:srgbClr>
+            </a:outerShdw>
+          </a:effectLst>
+        </p:spPr>
+      </p:pic>
+    </p:spTree>
+    <p:extLst>
+      <p:ext uri="{BB962C8B-B14F-4D97-AF65-F5344CB8AC3E}">
+        <p14:creationId xmlns:p14="http://schemas.microsoft.com/office/powerpoint/2010/main" val="2523154767"/>
+      </p:ext>
+    </p:extLst>
+  </p:cSld>
+  <p:clrMapOvr>
+    <a:masterClrMapping/>
+  </p:clrMapOvr>
+</p:sld>
+</file>
+
+<file path=ppt/slides/slide6.xml><?xml version="1.0" encoding="utf-8"?>
+<p:sld xmlns:a="http://schemas.openxmlformats.org/drawingml/2006/main" xmlns:r="http://schemas.openxmlformats.org/officeDocument/2006/relationships" xmlns:p="http://schemas.openxmlformats.org/presentationml/2006/main">
+  <p:cSld>
+    <p:spTree>
+      <p:nvGrpSpPr>
+        <p:cNvPr id="1" name="">
+          <a:extLst>
+            <a:ext uri="{FF2B5EF4-FFF2-40B4-BE49-F238E27FC236}">
+              <a16:creationId xmlns:a16="http://schemas.microsoft.com/office/drawing/2014/main" id="{8B119EFD-3E96-45B0-0B48-5BBB7830CB49}"/>
+            </a:ext>
+          </a:extLst>
+        </p:cNvPr>
+        <p:cNvGrpSpPr/>
+        <p:nvPr/>
+      </p:nvGrpSpPr>
+      <p:grpSpPr>
+        <a:xfrm>
+          <a:off x="0" y="0"/>
+          <a:ext cx="0" cy="0"/>
+          <a:chOff x="0" y="0"/>
+          <a:chExt cx="0" cy="0"/>
+        </a:xfrm>
+      </p:grpSpPr>
+      <p:sp>
+        <p:nvSpPr>
+          <p:cNvPr id="3" name="TextBox 2">
+            <a:extLst>
+              <a:ext uri="{FF2B5EF4-FFF2-40B4-BE49-F238E27FC236}">
+                <a16:creationId xmlns:a16="http://schemas.microsoft.com/office/drawing/2014/main" id="{9219B77C-93AA-58B6-20BE-D4D4A4F49566}"/>
+              </a:ext>
+            </a:extLst>
+          </p:cNvPr>
+          <p:cNvSpPr txBox="1"/>
+          <p:nvPr/>
+        </p:nvSpPr>
+        <p:spPr>
+          <a:xfrm>
+            <a:off x="217714" y="255046"/>
+            <a:ext cx="11756571" cy="1855764"/>
+          </a:xfrm>
+          <a:prstGeom prst="rect">
+            <a:avLst/>
+          </a:prstGeom>
+          <a:noFill/>
+        </p:spPr>
+        <p:txBody>
+          <a:bodyPr wrap="square">
+            <a:spAutoFit/>
+          </a:bodyPr>
+          <a:lstStyle/>
+          <a:p>
+            <a:pPr>
+              <a:lnSpc>
+                <a:spcPct val="150000"/>
+              </a:lnSpc>
+              <a:buNone/>
+            </a:pPr>
+            <a:r>
+              <a:rPr lang="en-US" altLang="en-US" sz="1300">
+                <a:latin typeface="Arial" panose="020B0604020202020204" pitchFamily="34" charset="0"/>
+              </a:rPr>
+              <a:t>app\Http\Controllers\Backend\ProductVariantController.php</a:t>
+            </a:r>
+          </a:p>
+          <a:p>
+            <a:pPr>
+              <a:lnSpc>
+                <a:spcPct val="150000"/>
+              </a:lnSpc>
+              <a:buNone/>
+            </a:pPr>
+            <a:endParaRPr kumimoji="0" lang="en-US" altLang="en-US" sz="1300" b="0" i="0" u="none" strike="noStrike" cap="none" normalizeH="0" baseline="0">
+              <a:ln>
+                <a:noFill/>
+              </a:ln>
+              <a:solidFill>
+                <a:schemeClr val="tx1"/>
+              </a:solidFill>
+              <a:effectLst/>
+              <a:latin typeface="Arial" panose="020B0604020202020204" pitchFamily="34" charset="0"/>
+            </a:endParaRPr>
+          </a:p>
+          <a:p>
+            <a:pPr>
+              <a:lnSpc>
+                <a:spcPct val="150000"/>
+              </a:lnSpc>
+              <a:buNone/>
+            </a:pPr>
+            <a:endParaRPr lang="en-US" altLang="en-US" sz="1300">
+              <a:latin typeface="Arial" panose="020B0604020202020204" pitchFamily="34" charset="0"/>
+            </a:endParaRPr>
+          </a:p>
+          <a:p>
+            <a:pPr>
+              <a:lnSpc>
+                <a:spcPct val="150000"/>
+              </a:lnSpc>
+              <a:buNone/>
+            </a:pPr>
+            <a:r>
+              <a:rPr kumimoji="0" lang="en-US" altLang="en-US" sz="1300" b="0" i="0" u="none" strike="noStrike" cap="none" normalizeH="0" baseline="0">
+                <a:ln>
+                  <a:noFill/>
+                </a:ln>
+                <a:solidFill>
+                  <a:schemeClr val="tx1"/>
+                </a:solidFill>
+                <a:effectLst/>
+                <a:latin typeface="Arial" panose="020B0604020202020204" pitchFamily="34" charset="0"/>
+              </a:rPr>
+              <a:t>store() metodunda</a:t>
+            </a:r>
+            <a:r>
+              <a:rPr kumimoji="0" lang="az-Latn-AZ" altLang="en-US" sz="1300" b="0" i="0" u="none" strike="noStrike" cap="none" normalizeH="0" baseline="0">
+                <a:ln>
+                  <a:noFill/>
+                </a:ln>
+                <a:solidFill>
+                  <a:schemeClr val="tx1"/>
+                </a:solidFill>
+                <a:effectLst/>
+                <a:latin typeface="Arial" panose="020B0604020202020204" pitchFamily="34" charset="0"/>
+              </a:rPr>
+              <a:t> Product</a:t>
+            </a:r>
+            <a:r>
+              <a:rPr kumimoji="0" lang="en-US" altLang="en-US" sz="1300" b="0" i="0" u="none" strike="noStrike" cap="none" normalizeH="0" baseline="0">
+                <a:ln>
+                  <a:noFill/>
+                </a:ln>
+                <a:solidFill>
+                  <a:schemeClr val="tx1"/>
+                </a:solidFill>
+                <a:effectLst/>
+                <a:latin typeface="Arial" panose="020B0604020202020204" pitchFamily="34" charset="0"/>
+              </a:rPr>
+              <a:t> identifikator</a:t>
+            </a:r>
+            <a:r>
+              <a:rPr kumimoji="0" lang="az-Latn-AZ" altLang="en-US" sz="1300" b="0" i="0" u="none" strike="noStrike" cap="none" normalizeH="0" baseline="0">
+                <a:ln>
+                  <a:noFill/>
+                </a:ln>
+                <a:solidFill>
+                  <a:schemeClr val="tx1"/>
+                </a:solidFill>
+                <a:effectLst/>
+                <a:latin typeface="Arial" panose="020B0604020202020204" pitchFamily="34" charset="0"/>
+              </a:rPr>
+              <a:t>unu qeyd etməsəydik,</a:t>
+            </a:r>
+          </a:p>
+          <a:p>
+            <a:pPr>
+              <a:lnSpc>
+                <a:spcPct val="150000"/>
+              </a:lnSpc>
+              <a:buNone/>
+            </a:pPr>
+            <a:r>
+              <a:rPr lang="az-Latn-AZ" altLang="en-US" sz="1300">
+                <a:latin typeface="Arial" panose="020B0604020202020204" pitchFamily="34" charset="0"/>
+              </a:rPr>
+              <a:t>route() metodu hansı məhsulu nəzərdə tutduğumuzu bilməzdi və</a:t>
+            </a:r>
+          </a:p>
+          <a:p>
+            <a:pPr>
+              <a:lnSpc>
+                <a:spcPct val="150000"/>
+              </a:lnSpc>
+              <a:buNone/>
+            </a:pPr>
+            <a:r>
+              <a:rPr kumimoji="0" lang="az-Latn-AZ" altLang="en-US" sz="1300" b="0" i="0" u="none" strike="noStrike" cap="none" normalizeH="0" baseline="0">
+                <a:ln>
+                  <a:noFill/>
+                </a:ln>
+                <a:solidFill>
+                  <a:schemeClr val="tx1"/>
+                </a:solidFill>
+                <a:effectLst/>
+                <a:latin typeface="Arial" panose="020B0604020202020204" pitchFamily="34" charset="0"/>
+              </a:rPr>
+              <a:t>xəta alardıq. 8 və 9 cu </a:t>
+            </a:r>
+            <a:r>
+              <a:rPr lang="az-Latn-AZ" altLang="en-US" sz="1300">
+                <a:latin typeface="Arial" panose="020B0604020202020204" pitchFamily="34" charset="0"/>
+              </a:rPr>
+              <a:t>slaydlarda olduğu kimi.</a:t>
+            </a:r>
+            <a:endParaRPr kumimoji="0" lang="en-US" altLang="en-US" sz="1300" b="0" i="0" u="none" strike="noStrike" cap="none" normalizeH="0" baseline="0">
+              <a:ln>
+                <a:noFill/>
+              </a:ln>
+              <a:solidFill>
+                <a:schemeClr val="tx1"/>
+              </a:solidFill>
+              <a:effectLst/>
+              <a:latin typeface="Arial" panose="020B0604020202020204" pitchFamily="34" charset="0"/>
+            </a:endParaRPr>
+          </a:p>
+        </p:txBody>
+      </p:sp>
+      <p:pic>
+        <p:nvPicPr>
+          <p:cNvPr id="4" name="Picture 3">
+            <a:extLst>
+              <a:ext uri="{FF2B5EF4-FFF2-40B4-BE49-F238E27FC236}">
+                <a16:creationId xmlns:a16="http://schemas.microsoft.com/office/drawing/2014/main" id="{976887A3-A2C3-9962-8FF9-C99846F89A4F}"/>
+              </a:ext>
+            </a:extLst>
+          </p:cNvPr>
+          <p:cNvPicPr>
+            <a:picLocks noChangeAspect="1"/>
+          </p:cNvPicPr>
+          <p:nvPr/>
+        </p:nvPicPr>
+        <p:blipFill>
+          <a:blip r:embed="rId2"/>
+          <a:stretch>
+            <a:fillRect/>
+          </a:stretch>
+        </p:blipFill>
+        <p:spPr>
+          <a:xfrm>
+            <a:off x="6336270" y="0"/>
+            <a:ext cx="5855730" cy="6858000"/>
+          </a:xfrm>
+          <a:prstGeom prst="rect">
+            <a:avLst/>
+          </a:prstGeom>
+        </p:spPr>
+      </p:pic>
+    </p:spTree>
+    <p:extLst>
+      <p:ext uri="{BB962C8B-B14F-4D97-AF65-F5344CB8AC3E}">
+        <p14:creationId xmlns:p14="http://schemas.microsoft.com/office/powerpoint/2010/main" val="2113906546"/>
+      </p:ext>
+    </p:extLst>
+  </p:cSld>
+  <p:clrMapOvr>
+    <a:masterClrMapping/>
+  </p:clrMapOvr>
+</p:sld>
+</file>
+
+<file path=ppt/slides/slide7.xml><?xml version="1.0" encoding="utf-8"?>
+<p:sld xmlns:a="http://schemas.openxmlformats.org/drawingml/2006/main" xmlns:r="http://schemas.openxmlformats.org/officeDocument/2006/relationships" xmlns:p="http://schemas.openxmlformats.org/presentationml/2006/main">
+  <p:cSld>
+    <p:spTree>
+      <p:nvGrpSpPr>
+        <p:cNvPr id="1" name="">
+          <a:extLst>
+            <a:ext uri="{FF2B5EF4-FFF2-40B4-BE49-F238E27FC236}">
+              <a16:creationId xmlns:a16="http://schemas.microsoft.com/office/drawing/2014/main" id="{A9B399A9-8A13-CE38-D4F1-DF4C14C5DEF5}"/>
+            </a:ext>
+          </a:extLst>
+        </p:cNvPr>
+        <p:cNvGrpSpPr/>
+        <p:nvPr/>
+      </p:nvGrpSpPr>
+      <p:grpSpPr>
+        <a:xfrm>
+          <a:off x="0" y="0"/>
+          <a:ext cx="0" cy="0"/>
+          <a:chOff x="0" y="0"/>
+          <a:chExt cx="0" cy="0"/>
+        </a:xfrm>
+      </p:grpSpPr>
+      <p:sp>
+        <p:nvSpPr>
+          <p:cNvPr id="3" name="TextBox 2">
+            <a:extLst>
+              <a:ext uri="{FF2B5EF4-FFF2-40B4-BE49-F238E27FC236}">
+                <a16:creationId xmlns:a16="http://schemas.microsoft.com/office/drawing/2014/main" id="{7DCB51BF-7F26-74E5-19FF-AFD1A0A18515}"/>
+              </a:ext>
+            </a:extLst>
+          </p:cNvPr>
+          <p:cNvSpPr txBox="1"/>
+          <p:nvPr/>
+        </p:nvSpPr>
+        <p:spPr>
+          <a:xfrm>
+            <a:off x="217714" y="255046"/>
+            <a:ext cx="11756571" cy="355354"/>
+          </a:xfrm>
+          <a:prstGeom prst="rect">
+            <a:avLst/>
+          </a:prstGeom>
+          <a:noFill/>
+        </p:spPr>
+        <p:txBody>
+          <a:bodyPr wrap="square">
+            <a:spAutoFit/>
+          </a:bodyPr>
+          <a:lstStyle/>
+          <a:p>
+            <a:pPr>
+              <a:lnSpc>
+                <a:spcPct val="150000"/>
+              </a:lnSpc>
+              <a:buNone/>
+            </a:pPr>
+            <a:r>
+              <a:rPr kumimoji="0" lang="en-US" altLang="en-US" sz="1300" b="0" i="0" u="none" strike="noStrike" cap="none" normalizeH="0" baseline="0">
+                <a:ln>
+                  <a:noFill/>
+                </a:ln>
+                <a:solidFill>
+                  <a:schemeClr val="tx1"/>
+                </a:solidFill>
+                <a:effectLst/>
+                <a:latin typeface="Arial" panose="020B0604020202020204" pitchFamily="34" charset="0"/>
+              </a:rPr>
+              <a:t>.</a:t>
+            </a:r>
+          </a:p>
+        </p:txBody>
+      </p:sp>
+      <p:pic>
+        <p:nvPicPr>
+          <p:cNvPr id="4" name="Picture 3">
+            <a:extLst>
+              <a:ext uri="{FF2B5EF4-FFF2-40B4-BE49-F238E27FC236}">
+                <a16:creationId xmlns:a16="http://schemas.microsoft.com/office/drawing/2014/main" id="{4CA908E9-4008-C25C-1E5B-756E6314E043}"/>
+              </a:ext>
+            </a:extLst>
+          </p:cNvPr>
+          <p:cNvPicPr>
+            <a:picLocks noChangeAspect="1"/>
+          </p:cNvPicPr>
+          <p:nvPr/>
+        </p:nvPicPr>
+        <p:blipFill>
+          <a:blip r:embed="rId2"/>
+          <a:stretch>
+            <a:fillRect/>
+          </a:stretch>
+        </p:blipFill>
+        <p:spPr>
+          <a:xfrm>
+            <a:off x="0" y="1445810"/>
+            <a:ext cx="12192000" cy="3966379"/>
+          </a:xfrm>
+          <a:prstGeom prst="rect">
+            <a:avLst/>
+          </a:prstGeom>
+          <a:ln>
+            <a:noFill/>
+          </a:ln>
+          <a:effectLst>
+            <a:outerShdw blurRad="292100" dist="139700" dir="2700000" algn="tl" rotWithShape="0">
+              <a:srgbClr val="333333">
+                <a:alpha val="65000"/>
+              </a:srgbClr>
+            </a:outerShdw>
+          </a:effectLst>
+        </p:spPr>
+      </p:pic>
+    </p:spTree>
+    <p:extLst>
+      <p:ext uri="{BB962C8B-B14F-4D97-AF65-F5344CB8AC3E}">
+        <p14:creationId xmlns:p14="http://schemas.microsoft.com/office/powerpoint/2010/main" val="1382844856"/>
+      </p:ext>
+    </p:extLst>
+  </p:cSld>
+  <p:clrMapOvr>
+    <a:masterClrMapping/>
+  </p:clrMapOvr>
+</p:sld>
+</file>
+
+<file path=ppt/slides/slide8.xml><?xml version="1.0" encoding="utf-8"?>
+<p:sld xmlns:a="http://schemas.openxmlformats.org/drawingml/2006/main" xmlns:r="http://schemas.openxmlformats.org/officeDocument/2006/relationships" xmlns:p="http://schemas.openxmlformats.org/presentationml/2006/main">
+  <p:cSld>
+    <p:spTree>
+      <p:nvGrpSpPr>
+        <p:cNvPr id="1" name="">
+          <a:extLst>
+            <a:ext uri="{FF2B5EF4-FFF2-40B4-BE49-F238E27FC236}">
+              <a16:creationId xmlns:a16="http://schemas.microsoft.com/office/drawing/2014/main" id="{AA5D3858-AD1A-6026-8C76-F2FE0CE1010C}"/>
+            </a:ext>
+          </a:extLst>
+        </p:cNvPr>
+        <p:cNvGrpSpPr/>
+        <p:nvPr/>
+      </p:nvGrpSpPr>
+      <p:grpSpPr>
+        <a:xfrm>
+          <a:off x="0" y="0"/>
+          <a:ext cx="0" cy="0"/>
+          <a:chOff x="0" y="0"/>
+          <a:chExt cx="0" cy="0"/>
+        </a:xfrm>
+      </p:grpSpPr>
+      <p:sp>
+        <p:nvSpPr>
+          <p:cNvPr id="3" name="TextBox 2">
+            <a:extLst>
+              <a:ext uri="{FF2B5EF4-FFF2-40B4-BE49-F238E27FC236}">
+                <a16:creationId xmlns:a16="http://schemas.microsoft.com/office/drawing/2014/main" id="{6AFE017F-6A1E-BD4D-C6D3-1D6447DC8D9B}"/>
+              </a:ext>
+            </a:extLst>
+          </p:cNvPr>
+          <p:cNvSpPr txBox="1"/>
+          <p:nvPr/>
+        </p:nvSpPr>
+        <p:spPr>
+          <a:xfrm>
+            <a:off x="217714" y="255046"/>
+            <a:ext cx="11756571" cy="355354"/>
+          </a:xfrm>
+          <a:prstGeom prst="rect">
+            <a:avLst/>
+          </a:prstGeom>
+          <a:noFill/>
+        </p:spPr>
+        <p:txBody>
+          <a:bodyPr wrap="square">
+            <a:spAutoFit/>
+          </a:bodyPr>
+          <a:lstStyle/>
+          <a:p>
+            <a:pPr>
+              <a:lnSpc>
+                <a:spcPct val="150000"/>
+              </a:lnSpc>
+              <a:buNone/>
+            </a:pPr>
+            <a:r>
+              <a:rPr lang="en-US" altLang="en-US" sz="1300">
+                <a:latin typeface="Arial" panose="020B0604020202020204" pitchFamily="34" charset="0"/>
+              </a:rPr>
+              <a:t>app\Http\Controllers\Backend\ProductVariantController.php</a:t>
+            </a:r>
+          </a:p>
+        </p:txBody>
+      </p:sp>
+      <p:pic>
+        <p:nvPicPr>
+          <p:cNvPr id="4" name="Picture 3">
+            <a:extLst>
+              <a:ext uri="{FF2B5EF4-FFF2-40B4-BE49-F238E27FC236}">
+                <a16:creationId xmlns:a16="http://schemas.microsoft.com/office/drawing/2014/main" id="{EA33C545-6B9C-F907-7289-DD31D97A2A21}"/>
+              </a:ext>
+            </a:extLst>
+          </p:cNvPr>
+          <p:cNvPicPr>
+            <a:picLocks noChangeAspect="1"/>
+          </p:cNvPicPr>
+          <p:nvPr/>
+        </p:nvPicPr>
+        <p:blipFill>
+          <a:blip r:embed="rId2"/>
+          <a:stretch>
+            <a:fillRect/>
+          </a:stretch>
+        </p:blipFill>
+        <p:spPr>
+          <a:xfrm>
+            <a:off x="6380347" y="0"/>
+            <a:ext cx="5878286" cy="6858000"/>
+          </a:xfrm>
+          <a:prstGeom prst="rect">
+            <a:avLst/>
+          </a:prstGeom>
+        </p:spPr>
+      </p:pic>
+    </p:spTree>
+    <p:extLst>
+      <p:ext uri="{BB962C8B-B14F-4D97-AF65-F5344CB8AC3E}">
+        <p14:creationId xmlns:p14="http://schemas.microsoft.com/office/powerpoint/2010/main" val="55898137"/>
+      </p:ext>
+    </p:extLst>
+  </p:cSld>
+  <p:clrMapOvr>
+    <a:masterClrMapping/>
+  </p:clrMapOvr>
+</p:sld>
+</file>
+
+<file path=ppt/slides/slide9.xml><?xml version="1.0" encoding="utf-8"?>
 <p:sld xmlns:a="http://schemas.openxmlformats.org/drawingml/2006/main" xmlns:r="http://schemas.openxmlformats.org/officeDocument/2006/relationships" xmlns:p="http://schemas.openxmlformats.org/presentationml/2006/main">
   <p:cSld>
     <p:spTree>
@@ -3470,96 +4774,40 @@
           </a:p>
         </p:txBody>
       </p:sp>
+      <p:pic>
+        <p:nvPicPr>
+          <p:cNvPr id="4" name="Picture 3">
+            <a:extLst>
+              <a:ext uri="{FF2B5EF4-FFF2-40B4-BE49-F238E27FC236}">
+                <a16:creationId xmlns:a16="http://schemas.microsoft.com/office/drawing/2014/main" id="{F060045B-A942-91BC-9025-77985FF62C51}"/>
+              </a:ext>
+            </a:extLst>
+          </p:cNvPr>
+          <p:cNvPicPr>
+            <a:picLocks noChangeAspect="1"/>
+          </p:cNvPicPr>
+          <p:nvPr/>
+        </p:nvPicPr>
+        <p:blipFill>
+          <a:blip r:embed="rId2"/>
+          <a:stretch>
+            <a:fillRect/>
+          </a:stretch>
+        </p:blipFill>
+        <p:spPr>
+          <a:xfrm>
+            <a:off x="0" y="2950960"/>
+            <a:ext cx="12192000" cy="3907040"/>
+          </a:xfrm>
+          <a:prstGeom prst="rect">
+            <a:avLst/>
+          </a:prstGeom>
+        </p:spPr>
+      </p:pic>
     </p:spTree>
     <p:extLst>
       <p:ext uri="{BB962C8B-B14F-4D97-AF65-F5344CB8AC3E}">
         <p14:creationId xmlns:p14="http://schemas.microsoft.com/office/powerpoint/2010/main" val="4233252692"/>
-      </p:ext>
-    </p:extLst>
-  </p:cSld>
-  <p:clrMapOvr>
-    <a:masterClrMapping/>
-  </p:clrMapOvr>
-</p:sld>
-</file>
-
-<file path=ppt/slides/slide3.xml><?xml version="1.0" encoding="utf-8"?>
-<p:sld xmlns:a="http://schemas.openxmlformats.org/drawingml/2006/main" xmlns:r="http://schemas.openxmlformats.org/officeDocument/2006/relationships" xmlns:p="http://schemas.openxmlformats.org/presentationml/2006/main">
-  <p:cSld>
-    <p:spTree>
-      <p:nvGrpSpPr>
-        <p:cNvPr id="1" name="">
-          <a:extLst>
-            <a:ext uri="{FF2B5EF4-FFF2-40B4-BE49-F238E27FC236}">
-              <a16:creationId xmlns:a16="http://schemas.microsoft.com/office/drawing/2014/main" id="{ECE25D7D-A080-F22B-7E8D-36EC827289A1}"/>
-            </a:ext>
-          </a:extLst>
-        </p:cNvPr>
-        <p:cNvGrpSpPr/>
-        <p:nvPr/>
-      </p:nvGrpSpPr>
-      <p:grpSpPr>
-        <a:xfrm>
-          <a:off x="0" y="0"/>
-          <a:ext cx="0" cy="0"/>
-          <a:chOff x="0" y="0"/>
-          <a:chExt cx="0" cy="0"/>
-        </a:xfrm>
-      </p:grpSpPr>
-      <p:sp>
-        <p:nvSpPr>
-          <p:cNvPr id="3" name="TextBox 2">
-            <a:extLst>
-              <a:ext uri="{FF2B5EF4-FFF2-40B4-BE49-F238E27FC236}">
-                <a16:creationId xmlns:a16="http://schemas.microsoft.com/office/drawing/2014/main" id="{E33F16A3-A6E8-401E-847B-09570DC6E4CB}"/>
-              </a:ext>
-            </a:extLst>
-          </p:cNvPr>
-          <p:cNvSpPr txBox="1"/>
-          <p:nvPr/>
-        </p:nvSpPr>
-        <p:spPr>
-          <a:xfrm>
-            <a:off x="217714" y="255046"/>
-            <a:ext cx="11756571" cy="355354"/>
-          </a:xfrm>
-          <a:prstGeom prst="rect">
-            <a:avLst/>
-          </a:prstGeom>
-          <a:noFill/>
-        </p:spPr>
-        <p:txBody>
-          <a:bodyPr wrap="square">
-            <a:spAutoFit/>
-          </a:bodyPr>
-          <a:lstStyle/>
-          <a:p>
-            <a:pPr>
-              <a:lnSpc>
-                <a:spcPct val="150000"/>
-              </a:lnSpc>
-              <a:buNone/>
-            </a:pPr>
-            <a:r>
-              <a:rPr kumimoji="0" lang="en-US" altLang="en-US" sz="1300" b="0" i="0" u="none" strike="noStrike" cap="none" normalizeH="0" baseline="0">
-                <a:ln>
-                  <a:noFill/>
-                </a:ln>
-                <a:solidFill>
-                  <a:schemeClr val="tx1"/>
-                </a:solidFill>
-                <a:effectLst/>
-                <a:latin typeface="Arial" panose="020B0604020202020204" pitchFamily="34" charset="0"/>
-              </a:rPr>
-              <a:t>.</a:t>
-            </a:r>
-          </a:p>
-        </p:txBody>
-      </p:sp>
-    </p:spTree>
-    <p:extLst>
-      <p:ext uri="{BB962C8B-B14F-4D97-AF65-F5344CB8AC3E}">
-        <p14:creationId xmlns:p14="http://schemas.microsoft.com/office/powerpoint/2010/main" val="3095838342"/>
       </p:ext>
     </p:extLst>
   </p:cSld>

</xml_diff>